<commit_message>
Recreations: independent audit 26/26 PASS after layout/master ph geom
</commit_message>
<xml_diff>
--- a/examples/recreations/20_Dropbox_Recreation__ExampleItinerary/out_mat2ppt.pptx
+++ b/examples/recreations/20_Dropbox_Recreation__ExampleItinerary/out_mat2ppt.pptx
@@ -3089,9 +3089,46 @@
         <p:nvPr/>
       </p:nvGrpSpPr>
       <p:grpSpPr/>
+      <p:sp>
+        <p:nvSpPr>
+          <p:cNvPr id="2" name="Rectangle 1"/>
+          <p:cNvSpPr/>
+          <p:nvPr/>
+        </p:nvSpPr>
+        <p:spPr>
+          <a:xfrm>
+            <a:off x="457200" y="274638"/>
+            <a:ext cx="8229600" cy="1143000"/>
+          </a:xfrm>
+          <a:prstGeom prst="rect">
+            <a:avLst/>
+          </a:prstGeom>
+        </p:spPr>
+        <p:style>
+          <a:lnRef idx="1">
+            <a:schemeClr val="accent1"/>
+          </a:lnRef>
+          <a:fillRef idx="3">
+            <a:schemeClr val="accent1"/>
+          </a:fillRef>
+          <a:effectRef idx="2">
+            <a:schemeClr val="accent1"/>
+          </a:effectRef>
+          <a:fontRef idx="minor">
+            <a:schemeClr val="lt1"/>
+          </a:fontRef>
+        </p:style>
+        <p:txBody>
+          <a:bodyPr rtlCol="0" anchor="ctr"/>
+          <a:lstStyle/>
+          <a:p>
+            <a:pPr algn="ctr"/>
+          </a:p>
+        </p:txBody>
+      </p:sp>
       <p:pic>
         <p:nvPicPr>
-          <p:cNvPr id="2" name="Picture 1" descr="image1.jpeg"/>
+          <p:cNvPr id="3" name="Picture 2" descr="image1.jpeg"/>
           <p:cNvPicPr>
             <a:picLocks noChangeAspect="1"/>
           </p:cNvPicPr>
@@ -3131,9 +3168,46 @@
         <p:nvPr/>
       </p:nvGrpSpPr>
       <p:grpSpPr/>
+      <p:sp>
+        <p:nvSpPr>
+          <p:cNvPr id="2" name="Rectangle 1"/>
+          <p:cNvSpPr/>
+          <p:nvPr/>
+        </p:nvSpPr>
+        <p:spPr>
+          <a:xfrm>
+            <a:off x="457200" y="274638"/>
+            <a:ext cx="8229600" cy="1143000"/>
+          </a:xfrm>
+          <a:prstGeom prst="rect">
+            <a:avLst/>
+          </a:prstGeom>
+        </p:spPr>
+        <p:style>
+          <a:lnRef idx="1">
+            <a:schemeClr val="accent1"/>
+          </a:lnRef>
+          <a:fillRef idx="3">
+            <a:schemeClr val="accent1"/>
+          </a:fillRef>
+          <a:effectRef idx="2">
+            <a:schemeClr val="accent1"/>
+          </a:effectRef>
+          <a:fontRef idx="minor">
+            <a:schemeClr val="lt1"/>
+          </a:fontRef>
+        </p:style>
+        <p:txBody>
+          <a:bodyPr rtlCol="0" anchor="ctr"/>
+          <a:lstStyle/>
+          <a:p>
+            <a:pPr algn="ctr"/>
+          </a:p>
+        </p:txBody>
+      </p:sp>
       <p:pic>
         <p:nvPicPr>
-          <p:cNvPr id="2" name="Picture 1" descr="image1.jpeg"/>
+          <p:cNvPr id="3" name="Picture 2" descr="image1.jpeg"/>
           <p:cNvPicPr>
             <a:picLocks noChangeAspect="1"/>
           </p:cNvPicPr>
@@ -3157,7 +3231,7 @@
       </p:pic>
       <p:pic>
         <p:nvPicPr>
-          <p:cNvPr id="3" name="Picture 2" descr="image1.jpeg"/>
+          <p:cNvPr id="4" name="Picture 3" descr="image1.jpeg"/>
           <p:cNvPicPr>
             <a:picLocks noChangeAspect="1"/>
           </p:cNvPicPr>

</xml_diff>